<commit_message>
docs(deck): add a longevity slide on versioning and provenance
Twelfth slide, "Six months later, when someone asks why" — the part of
DESIGN_NOTES a reviewer will probe but that no screenshot shows: the four
independent identities every artifact carries, why the patch number is the
repair count, byte-reproducible packaging, and which parts of the system are
data rather than code.

It closes on the honest half of the extensibility claim: Oracle is a config
entry, Snowflake is not, and saying which is which is more useful than
claiming both are easy.

Placed last on purpose. The product screenshots are the emotional peak; the
argument for why it holds up is a better note to end on than a screenshot.

Co-Authored-By: Claude Opus 5 <noreply@anthropic.com>
</commit_message>
<xml_diff>
--- a/docs/Data-Source-Onboarding-Agent.pptx
+++ b/docs/Data-Source-Onboarding-Agent.pptx
@@ -16,6 +16,7 @@
     <p:sldId id="264" r:id="rId15"/>
     <p:sldId id="265" r:id="rId16"/>
     <p:sldId id="266" r:id="rId17"/>
+    <p:sldId id="267" r:id="rId18"/>
   </p:sldIdLst>
   <p:sldSz cx="12191695" cy="6858000" type="screen4x3"/>
   <p:notesSz cx="6858000" cy="9144000"/>
@@ -3682,6 +3683,380 @@
                 <a:latin typeface="Arial"/>
               </a:rPr>
               <a:t>Connector, README, requirements, explanation and a manifest, packaged as a versioned zip. The model reads intent; the template writes the code; the checker decides what ships.</a:t>
+            </a:r>
+          </a:p>
+        </p:txBody>
+      </p:sp>
+    </p:spTree>
+  </p:cSld>
+  <p:clrMapOvr>
+    <a:masterClrMapping/>
+  </p:clrMapOvr>
+</p:sld>
+</file>
+
+<file path=ppt/slides/slide12.xml><?xml version="1.0" encoding="utf-8"?>
+<p:sld xmlns:a="http://schemas.openxmlformats.org/drawingml/2006/main" xmlns:p="http://schemas.openxmlformats.org/presentationml/2006/main" xmlns:r="http://schemas.openxmlformats.org/officeDocument/2006/relationships">
+  <p:cSld>
+    <p:spTree>
+      <p:nvGrpSpPr>
+        <p:cNvPr id="1" name=""/>
+        <p:cNvGrpSpPr/>
+        <p:nvPr/>
+      </p:nvGrpSpPr>
+      <p:grpSpPr/>
+      <p:sp>
+        <p:nvSpPr>
+          <p:cNvPr id="2" name="Rectangle 1"/>
+          <p:cNvSpPr/>
+          <p:nvPr/>
+        </p:nvSpPr>
+        <p:spPr>
+          <a:xfrm>
+            <a:off x="0" y="0"/>
+            <a:ext cx="12191695" cy="6858000"/>
+          </a:xfrm>
+          <a:prstGeom prst="rect">
+            <a:avLst/>
+          </a:prstGeom>
+          <a:solidFill>
+            <a:srgbClr val="0A0F1C"/>
+          </a:solidFill>
+          <a:ln>
+            <a:noFill/>
+          </a:ln>
+          <a:effectLst/>
+        </p:spPr>
+        <p:style>
+          <a:lnRef idx="1">
+            <a:schemeClr val="accent1"/>
+          </a:lnRef>
+          <a:fillRef idx="3">
+            <a:schemeClr val="accent1"/>
+          </a:fillRef>
+          <a:effectRef idx="2">
+            <a:schemeClr val="accent1"/>
+          </a:effectRef>
+          <a:fontRef idx="minor">
+            <a:schemeClr val="lt1"/>
+          </a:fontRef>
+        </p:style>
+        <p:txBody>
+          <a:bodyPr rtlCol="0" anchor="ctr"/>
+          <a:lstStyle/>
+          <a:p>
+            <a:pPr algn="ctr"/>
+          </a:p>
+        </p:txBody>
+      </p:sp>
+      <p:sp>
+        <p:nvSpPr>
+          <p:cNvPr id="3" name="TextBox 2"/>
+          <p:cNvSpPr txBox="1"/>
+          <p:nvPr/>
+        </p:nvSpPr>
+        <p:spPr>
+          <a:xfrm>
+            <a:off x="685800" y="457200"/>
+            <a:ext cx="10058400" cy="274320"/>
+          </a:xfrm>
+          <a:prstGeom prst="rect">
+            <a:avLst/>
+          </a:prstGeom>
+          <a:noFill/>
+        </p:spPr>
+        <p:txBody>
+          <a:bodyPr wrap="square" lIns="0" rIns="0" tIns="0" bIns="0">
+            <a:spAutoFit/>
+          </a:bodyPr>
+          <a:lstStyle/>
+          <a:p>
+            <a:pPr>
+              <a:spcAft>
+                <a:spcPts val="600"/>
+              </a:spcAft>
+            </a:pPr>
+            <a:r>
+              <a:rPr sz="1100" b="1">
+                <a:solidFill>
+                  <a:srgbClr val="4B5975"/>
+                </a:solidFill>
+                <a:latin typeface="Courier New"/>
+              </a:rPr>
+              <a:t>LONGEVITY</a:t>
+            </a:r>
+          </a:p>
+        </p:txBody>
+      </p:sp>
+      <p:sp>
+        <p:nvSpPr>
+          <p:cNvPr id="4" name="TextBox 3"/>
+          <p:cNvSpPr txBox="1"/>
+          <p:nvPr/>
+        </p:nvSpPr>
+        <p:spPr>
+          <a:xfrm>
+            <a:off x="685800" y="777240"/>
+            <a:ext cx="10789920" cy="914400"/>
+          </a:xfrm>
+          <a:prstGeom prst="rect">
+            <a:avLst/>
+          </a:prstGeom>
+          <a:noFill/>
+        </p:spPr>
+        <p:txBody>
+          <a:bodyPr wrap="square" lIns="0" rIns="0" tIns="0" bIns="0">
+            <a:spAutoFit/>
+          </a:bodyPr>
+          <a:lstStyle/>
+          <a:p>
+            <a:pPr>
+              <a:spcAft>
+                <a:spcPts val="600"/>
+              </a:spcAft>
+            </a:pPr>
+            <a:r>
+              <a:rPr sz="3000" b="1">
+                <a:solidFill>
+                  <a:srgbClr val="E8EDF5"/>
+                </a:solidFill>
+                <a:latin typeface="Arial"/>
+              </a:rPr>
+              <a:t>Six months later, when someone asks why</a:t>
+            </a:r>
+          </a:p>
+        </p:txBody>
+      </p:sp>
+      <p:sp>
+        <p:nvSpPr>
+          <p:cNvPr id="5" name="Rectangle 4"/>
+          <p:cNvSpPr/>
+          <p:nvPr/>
+        </p:nvSpPr>
+        <p:spPr>
+          <a:xfrm>
+            <a:off x="685800" y="1691640"/>
+            <a:ext cx="10789920" cy="9525"/>
+          </a:xfrm>
+          <a:prstGeom prst="rect">
+            <a:avLst/>
+          </a:prstGeom>
+          <a:solidFill>
+            <a:srgbClr val="1F2A40"/>
+          </a:solidFill>
+          <a:ln>
+            <a:noFill/>
+          </a:ln>
+          <a:effectLst/>
+        </p:spPr>
+        <p:style>
+          <a:lnRef idx="1">
+            <a:schemeClr val="accent1"/>
+          </a:lnRef>
+          <a:fillRef idx="3">
+            <a:schemeClr val="accent1"/>
+          </a:fillRef>
+          <a:effectRef idx="2">
+            <a:schemeClr val="accent1"/>
+          </a:effectRef>
+          <a:fontRef idx="minor">
+            <a:schemeClr val="lt1"/>
+          </a:fontRef>
+        </p:style>
+        <p:txBody>
+          <a:bodyPr rtlCol="0" anchor="ctr"/>
+          <a:lstStyle/>
+          <a:p>
+            <a:pPr algn="ctr"/>
+          </a:p>
+        </p:txBody>
+      </p:sp>
+      <p:sp>
+        <p:nvSpPr>
+          <p:cNvPr id="6" name="TextBox 5"/>
+          <p:cNvSpPr txBox="1"/>
+          <p:nvPr/>
+        </p:nvSpPr>
+        <p:spPr>
+          <a:xfrm>
+            <a:off x="685800" y="1965960"/>
+            <a:ext cx="10789920" cy="4023360"/>
+          </a:xfrm>
+          <a:prstGeom prst="rect">
+            <a:avLst/>
+          </a:prstGeom>
+          <a:noFill/>
+        </p:spPr>
+        <p:txBody>
+          <a:bodyPr wrap="square" lIns="0" rIns="0" tIns="0" bIns="0">
+            <a:spAutoFit/>
+          </a:bodyPr>
+          <a:lstStyle/>
+          <a:p>
+            <a:pPr>
+              <a:spcAft>
+                <a:spcPts val="300"/>
+              </a:spcAft>
+            </a:pPr>
+            <a:r>
+              <a:rPr sz="1700" b="1">
+                <a:solidFill>
+                  <a:srgbClr val="E8EDF5"/>
+                </a:solidFill>
+                <a:latin typeface="Arial"/>
+              </a:rPr>
+              <a:t>Every artifact carries four independent identities</a:t>
+            </a:r>
+          </a:p>
+          <a:p>
+            <a:pPr>
+              <a:spcAft>
+                <a:spcPts val="1600"/>
+              </a:spcAft>
+            </a:pPr>
+            <a:r>
+              <a:rPr sz="1450" b="0">
+                <a:solidFill>
+                  <a:srgbClr val="8896B0"/>
+                </a:solidFill>
+                <a:latin typeface="Arial"/>
+              </a:rPr>
+              <a:t>The template version that shaped it, a checksum of the request it came from, a checksum of the exact bytes emitted, and a version whose patch number is the repair count — so 1.0.2 reads as “template 1.0, needed two repair passes”, and a connector that struggled is visible at a glance.</a:t>
+            </a:r>
+          </a:p>
+          <a:p>
+            <a:pPr>
+              <a:spcAft>
+                <a:spcPts val="300"/>
+              </a:spcAft>
+            </a:pPr>
+            <a:r>
+              <a:rPr sz="1700" b="1">
+                <a:solidFill>
+                  <a:srgbClr val="E8EDF5"/>
+                </a:solidFill>
+                <a:latin typeface="Arial"/>
+              </a:rPr>
+              <a:t>Packaging is byte-reproducible</a:t>
+            </a:r>
+          </a:p>
+          <a:p>
+            <a:pPr>
+              <a:spcAft>
+                <a:spcPts val="1600"/>
+              </a:spcAft>
+            </a:pPr>
+            <a:r>
+              <a:rPr sz="1450" b="0">
+                <a:solidFill>
+                  <a:srgbClr val="8896B0"/>
+                </a:solidFill>
+                <a:latin typeface="Arial"/>
+              </a:rPr>
+              <a:t>The bundle is written with a fixed timestamp rather than the clock, so building the same artifact twice produces identical bytes. “Is this the file we shipped?” becomes a comparison instead of a memory.</a:t>
+            </a:r>
+          </a:p>
+          <a:p>
+            <a:pPr>
+              <a:spcAft>
+                <a:spcPts val="300"/>
+              </a:spcAft>
+            </a:pPr>
+            <a:r>
+              <a:rPr sz="1700" b="1">
+                <a:solidFill>
+                  <a:srgbClr val="E8EDF5"/>
+                </a:solidFill>
+                <a:latin typeface="Arial"/>
+              </a:rPr>
+              <a:t>The parts that change most often are data, not code</a:t>
+            </a:r>
+          </a:p>
+          <a:p>
+            <a:pPr>
+              <a:spcAft>
+                <a:spcPts val="1600"/>
+              </a:spcAft>
+            </a:pPr>
+            <a:r>
+              <a:rPr sz="1450" b="0">
+                <a:solidFill>
+                  <a:srgbClr val="8896B0"/>
+                </a:solidFill>
+                <a:latin typeface="Arial"/>
+              </a:rPr>
+              <a:t>Source types are generated from a JSON file at import — one entry brings the dialect profile, the clarifying-question options and the registry key with it. Adding a fourteenth standards check is one function and one list entry.</a:t>
+            </a:r>
+          </a:p>
+          <a:p>
+            <a:pPr>
+              <a:spcAft>
+                <a:spcPts val="300"/>
+              </a:spcAft>
+            </a:pPr>
+            <a:r>
+              <a:rPr sz="1700" b="1">
+                <a:solidFill>
+                  <a:srgbClr val="E8EDF5"/>
+                </a:solidFill>
+                <a:latin typeface="Arial"/>
+              </a:rPr>
+              <a:t>Where that stops being true, it is written down</a:t>
+            </a:r>
+          </a:p>
+          <a:p>
+            <a:pPr>
+              <a:spcAft>
+                <a:spcPts val="1600"/>
+              </a:spcAft>
+            </a:pPr>
+            <a:r>
+              <a:rPr sz="1450" b="0">
+                <a:solidFill>
+                  <a:srgbClr val="8896B0"/>
+                </a:solidFill>
+                <a:latin typeface="Arial"/>
+              </a:rPr>
+              <a:t>Oracle is a config change; Snowflake needs a new authentication method as well, because key-pair and SSO do not fit the username/password shape. Saying which is which is more useful than claiming both are easy.</a:t>
+            </a:r>
+          </a:p>
+        </p:txBody>
+      </p:sp>
+      <p:sp>
+        <p:nvSpPr>
+          <p:cNvPr id="7" name="TextBox 6"/>
+          <p:cNvSpPr txBox="1"/>
+          <p:nvPr/>
+        </p:nvSpPr>
+        <p:spPr>
+          <a:xfrm>
+            <a:off x="685800" y="5989320"/>
+            <a:ext cx="10789920" cy="548640"/>
+          </a:xfrm>
+          <a:prstGeom prst="rect">
+            <a:avLst/>
+          </a:prstGeom>
+          <a:noFill/>
+        </p:spPr>
+        <p:txBody>
+          <a:bodyPr wrap="square" lIns="0" rIns="0" tIns="0" bIns="0">
+            <a:spAutoFit/>
+          </a:bodyPr>
+          <a:lstStyle/>
+          <a:p>
+            <a:pPr>
+              <a:spcAft>
+                <a:spcPts val="600"/>
+              </a:spcAft>
+            </a:pPr>
+            <a:r>
+              <a:rPr sz="1250" b="0">
+                <a:solidFill>
+                  <a:srgbClr val="8896B0"/>
+                </a:solidFill>
+                <a:latin typeface="Courier New"/>
+              </a:rPr>
+              <a:t>None of this depends on someone remembering to fill it in — provenance is recorded by the pipeline that produces the artifact.</a:t>
             </a:r>
           </a:p>
         </p:txBody>

</xml_diff>

<commit_message>
docs(deck): end on a conclusion rather than a longevity aside
The last slide argued for the design's durability, which reads as future work
and is a thin note to finish on. Replaced with a conclusion that closes the
argument the deck opened: it works end to end today, the guarantee is
structural rather than aspirational, every artifact accounts for itself, and
it runs on every platform the team might use.

The versioning and provenance material is not lost — it is the third point,
where it does more work as evidence for the conclusion than it did as a
subject of its own.

Test count refreshed to 294 on both the stack slide and the closing figures,
now that the portability suite is in.

Co-Authored-By: Claude Opus 5 <noreply@anthropic.com>
</commit_message>
<xml_diff>
--- a/docs/Data-Source-Onboarding-Agent.pptx
+++ b/docs/Data-Source-Onboarding-Agent.pptx
@@ -3783,7 +3783,7 @@
                 </a:solidFill>
                 <a:latin typeface="Courier New"/>
               </a:rPr>
-              <a:t>LONGEVITY</a:t>
+              <a:t>CONCLUSION</a:t>
             </a:r>
           </a:p>
         </p:txBody>
@@ -3822,7 +3822,7 @@
                 </a:solidFill>
                 <a:latin typeface="Arial"/>
               </a:rPr>
-              <a:t>Six months later, when someone asks why</a:t>
+              <a:t>Standards you can prove, not standards you hope for</a:t>
             </a:r>
           </a:p>
         </p:txBody>
@@ -3905,7 +3905,7 @@
                 </a:solidFill>
                 <a:latin typeface="Arial"/>
               </a:rPr>
-              <a:t>Every artifact carries four independent identities</a:t>
+              <a:t>It works end to end, today</a:t>
             </a:r>
           </a:p>
           <a:p>
@@ -3921,7 +3921,7 @@
                 </a:solidFill>
                 <a:latin typeface="Arial"/>
               </a:rPr>
-              <a:t>The template version that shaped it, a checksum of the request it came from, a checksum of the exact bytes emitted, and a version whose patch number is the repair count — so 1.0.2 reads as “template 1.0, needed two repair passes”, and a connector that struggled is visible at a glance.</a:t>
+              <a:t>Plain English to a spec, a spec to a rendered connector, thirteen machine checks, a live connection test against a real PostgreSQL, and a versioned bundle you can hand over. Every screenshot in this deck is that pipeline running — none of it is a mockup.</a:t>
             </a:r>
           </a:p>
           <a:p>
@@ -3937,7 +3937,7 @@
                 </a:solidFill>
                 <a:latin typeface="Arial"/>
               </a:rPr>
-              <a:t>Packaging is byte-reproducible</a:t>
+              <a:t>The guarantee is structural, not aspirational</a:t>
             </a:r>
           </a:p>
           <a:p>
@@ -3953,7 +3953,7 @@
                 </a:solidFill>
                 <a:latin typeface="Arial"/>
               </a:rPr>
-              <a:t>The bundle is written with a fixed timestamp rather than the clock, so building the same artifact twice produces identical bytes. “Is this the file we shipped?” becomes a comparison instead of a memory.</a:t>
+              <a:t>The model fills a form; a template writes the code; a checker decides what ships. That separation is why the promise holds for the fortieth connector and not just the one being demonstrated.</a:t>
             </a:r>
           </a:p>
           <a:p>
@@ -3969,7 +3969,7 @@
                 </a:solidFill>
                 <a:latin typeface="Arial"/>
               </a:rPr>
-              <a:t>The parts that change most often are data, not code</a:t>
+              <a:t>Every artifact can account for itself</a:t>
             </a:r>
           </a:p>
           <a:p>
@@ -3985,7 +3985,7 @@
                 </a:solidFill>
                 <a:latin typeface="Arial"/>
               </a:rPr>
-              <a:t>Source types are generated from a JSON file at import — one entry brings the dialect profile, the clarifying-question options and the registry key with it. Adding a fourteenth standards check is one function and one list entry.</a:t>
+              <a:t>Template version, spec checksum, code checksum, and a repair count carried in the version number — packaged byte-reproducibly. Six months on, “why is this in production?” is a lookup rather than an argument.</a:t>
             </a:r>
           </a:p>
           <a:p>
@@ -4001,7 +4001,7 @@
                 </a:solidFill>
                 <a:latin typeface="Arial"/>
               </a:rPr>
-              <a:t>Where that stops being true, it is written down</a:t>
+              <a:t>It runs where the team runs</a:t>
             </a:r>
           </a:p>
           <a:p>
@@ -4017,7 +4017,7 @@
                 </a:solidFill>
                 <a:latin typeface="Arial"/>
               </a:rPr>
-              <a:t>Oracle is a config change; Snowflake needs a new authentication method as well, because key-pair and SSO do not fit the username/password shape. Saying which is which is more useful than claiming both are easy.</a:t>
+              <a:t>macOS, Linux and Windows, with the cross-platform invariants asserted by the test suite rather than assumed — so a change that would only break one of them fails on all of them.</a:t>
             </a:r>
           </a:p>
         </p:txBody>
@@ -4056,7 +4056,7 @@
                 </a:solidFill>
                 <a:latin typeface="Courier New"/>
               </a:rPr>
-              <a:t>None of this depends on someone remembering to fill it in — provenance is recorded by the pipeline that produces the artifact.</a:t>
+              <a:t>294 tests · 13 standards checks · 4 source types · 100% conformance on accepted artifacts</a:t>
             </a:r>
           </a:p>
         </p:txBody>
@@ -8873,7 +8873,7 @@
                           </a:solidFill>
                           <a:latin typeface="Arial"/>
                         </a:rPr>
-                        <a:t>pytest — 280 of them</a:t>
+                        <a:t>pytest — 294 of them</a:t>
                       </a:r>
                     </a:p>
                   </a:txBody>

</xml_diff>